<commit_message>
Brighten action routes, clarify physical fork and restore complete action wording
</commit_message>
<xml_diff>
--- a/slide-canvas/fork-only/downloads/LLA_Fork_A_Editable.pptx
+++ b/slide-canvas/fork-only/downloads/LLA_Fork_A_Editable.pptx
@@ -931,8 +931,8 @@
         </p:nvSpPr>
         <p:spPr>
           <a:xfrm>
-            <a:off x="1047750" y="619125"/>
-            <a:ext cx="8572500" cy="1428750"/>
+            <a:off x="762000" y="457200"/>
+            <a:ext cx="8572500" cy="1381125"/>
           </a:xfrm>
           <a:prstGeom prst="rect">
             <a:avLst/>
@@ -950,7 +950,7 @@
             <a:r>
               <a:rPr lang="en-US" sz="8850" dirty="0">
                 <a:solidFill>
-                  <a:srgbClr val="F4F1EA"/>
+                  <a:srgbClr val="0A1428"/>
                 </a:solidFill>
                 <a:latin typeface="Playfair Display" pitchFamily="34" charset="0"/>
                 <a:ea typeface="Playfair Display" pitchFamily="34" charset="-122"/>
@@ -970,8 +970,8 @@
         </p:nvSpPr>
         <p:spPr>
           <a:xfrm>
-            <a:off x="7953375" y="752475"/>
-            <a:ext cx="9239250" cy="1333500"/>
+            <a:off x="7715250" y="590550"/>
+            <a:ext cx="9810750" cy="1333500"/>
           </a:xfrm>
           <a:prstGeom prst="rect">
             <a:avLst/>
@@ -989,7 +989,7 @@
             <a:r>
               <a:rPr lang="en-US" sz="7500" i="1" dirty="0">
                 <a:solidFill>
-                  <a:srgbClr val="70E6D3"/>
+                  <a:srgbClr val="087F78"/>
                 </a:solidFill>
                 <a:latin typeface="Playfair Display" pitchFamily="34" charset="0"/>
                 <a:ea typeface="Playfair Display" pitchFamily="34" charset="-122"/>
@@ -1009,8 +1009,8 @@
         </p:nvSpPr>
         <p:spPr>
           <a:xfrm>
-            <a:off x="1000125" y="6381750"/>
-            <a:ext cx="6096000" cy="857250"/>
+            <a:off x="714375" y="6858000"/>
+            <a:ext cx="5619750" cy="857250"/>
           </a:xfrm>
           <a:prstGeom prst="rect">
             <a:avLst/>
@@ -1026,9 +1026,9 @@
               <a:buNone/>
             </a:pPr>
             <a:r>
-              <a:rPr lang="en-US" sz="4800" dirty="0">
+              <a:rPr lang="en-US" sz="4650" dirty="0">
                 <a:solidFill>
-                  <a:srgbClr val="CFD7E7"/>
+                  <a:srgbClr val="0A1428"/>
                 </a:solidFill>
                 <a:latin typeface="Playfair Display" pitchFamily="34" charset="0"/>
                 <a:ea typeface="Playfair Display" pitchFamily="34" charset="-122"/>
@@ -1036,7 +1036,7 @@
               </a:rPr>
               <a:t>Change nothing.</a:t>
             </a:r>
-            <a:endParaRPr lang="en-US" sz="4800" dirty="0"/>
+            <a:endParaRPr lang="en-US" sz="4650" dirty="0"/>
           </a:p>
         </p:txBody>
       </p:sp>
@@ -1048,8 +1048,8 @@
         </p:nvSpPr>
         <p:spPr>
           <a:xfrm>
-            <a:off x="1047750" y="7239000"/>
-            <a:ext cx="5810250" cy="552450"/>
+            <a:off x="762000" y="7715250"/>
+            <a:ext cx="4953000" cy="571500"/>
           </a:xfrm>
           <a:prstGeom prst="rect">
             <a:avLst/>
@@ -1065,17 +1065,17 @@
               <a:buNone/>
             </a:pPr>
             <a:r>
-              <a:rPr lang="en-US" sz="2625" dirty="0">
+              <a:rPr lang="en-US" sz="2550" dirty="0">
                 <a:solidFill>
-                  <a:srgbClr val="AAB8CE"/>
+                  <a:srgbClr val="0A1428"/>
                 </a:solidFill>
                 <a:latin typeface="Inter" pitchFamily="34" charset="0"/>
                 <a:ea typeface="Inter" pitchFamily="34" charset="-122"/>
                 <a:cs typeface="Inter" pitchFamily="34" charset="-120"/>
               </a:rPr>
-              <a:t>Keep the same habits.</a:t>
-            </a:r>
-            <a:endParaRPr lang="en-US" sz="2625" dirty="0"/>
+              <a:t>Decline is the default.</a:t>
+            </a:r>
+            <a:endParaRPr lang="en-US" sz="2550" dirty="0"/>
           </a:p>
         </p:txBody>
       </p:sp>
@@ -1087,8 +1087,8 @@
         </p:nvSpPr>
         <p:spPr>
           <a:xfrm>
-            <a:off x="11430000" y="2762250"/>
-            <a:ext cx="6191250" cy="809625"/>
+            <a:off x="13335000" y="2143125"/>
+            <a:ext cx="4572000" cy="762000"/>
           </a:xfrm>
           <a:prstGeom prst="rect">
             <a:avLst/>
@@ -1104,9 +1104,9 @@
               <a:buNone/>
             </a:pPr>
             <a:r>
-              <a:rPr lang="en-US" sz="5100" dirty="0">
+              <a:rPr lang="en-US" sz="4950" dirty="0">
                 <a:solidFill>
-                  <a:srgbClr val="F4F1EA"/>
+                  <a:srgbClr val="087F78"/>
                 </a:solidFill>
                 <a:latin typeface="Playfair Display" pitchFamily="34" charset="0"/>
                 <a:ea typeface="Playfair Display" pitchFamily="34" charset="-122"/>
@@ -1114,7 +1114,7 @@
               </a:rPr>
               <a:t>Choose action.</a:t>
             </a:r>
-            <a:endParaRPr lang="en-US" sz="5100" dirty="0"/>
+            <a:endParaRPr lang="en-US" sz="4950" dirty="0"/>
           </a:p>
         </p:txBody>
       </p:sp>
@@ -1126,8 +1126,8 @@
         </p:nvSpPr>
         <p:spPr>
           <a:xfrm>
-            <a:off x="11477625" y="3600450"/>
-            <a:ext cx="6096000" cy="476250"/>
+            <a:off x="13382625" y="2905125"/>
+            <a:ext cx="4524375" cy="457200"/>
           </a:xfrm>
           <a:prstGeom prst="rect">
             <a:avLst/>
@@ -1143,17 +1143,17 @@
               <a:buNone/>
             </a:pPr>
             <a:r>
-              <a:rPr lang="en-US" sz="2400" dirty="0">
+              <a:rPr lang="en-US" sz="2250" dirty="0">
                 <a:solidFill>
-                  <a:srgbClr val="BCEFE4"/>
+                  <a:srgbClr val="294F5C"/>
                 </a:solidFill>
                 <a:latin typeface="Inter" pitchFamily="34" charset="0"/>
                 <a:ea typeface="Inter" pitchFamily="34" charset="-122"/>
                 <a:cs typeface="Inter" pitchFamily="34" charset="-120"/>
               </a:rPr>
-              <a:t>Toward a longer, healthier life.</a:t>
-            </a:r>
-            <a:endParaRPr lang="en-US" sz="2400" dirty="0"/>
+              <a:t>Toward a longer, better life.</a:t>
+            </a:r>
+            <a:endParaRPr lang="en-US" sz="2250" dirty="0"/>
           </a:p>
         </p:txBody>
       </p:sp>
@@ -1165,8 +1165,8 @@
         </p:nvSpPr>
         <p:spPr>
           <a:xfrm>
-            <a:off x="10572750" y="8334375"/>
-            <a:ext cx="1714500" cy="571500"/>
+            <a:off x="13335000" y="3667125"/>
+            <a:ext cx="4572000" cy="666750"/>
           </a:xfrm>
           <a:prstGeom prst="rect">
             <a:avLst/>
@@ -1182,17 +1182,17 @@
               <a:buNone/>
             </a:pPr>
             <a:r>
-              <a:rPr lang="en-US" sz="2400" dirty="0">
+              <a:rPr lang="en-US" sz="3675" dirty="0">
                 <a:solidFill>
-                  <a:srgbClr val="F4F1EA"/>
+                  <a:srgbClr val="0A1428"/>
                 </a:solidFill>
                 <a:latin typeface="Playfair Display" pitchFamily="34" charset="0"/>
                 <a:ea typeface="Playfair Display" pitchFamily="34" charset="-122"/>
                 <a:cs typeface="Playfair Display" pitchFamily="34" charset="-120"/>
               </a:rPr>
-              <a:t>Move more.</a:t>
-            </a:r>
-            <a:endParaRPr lang="en-US" sz="2400" dirty="0"/>
+              <a:t>Start moving.</a:t>
+            </a:r>
+            <a:endParaRPr lang="en-US" sz="3675" dirty="0"/>
           </a:p>
         </p:txBody>
       </p:sp>
@@ -1204,8 +1204,8 @@
         </p:nvSpPr>
         <p:spPr>
           <a:xfrm>
-            <a:off x="10572750" y="8858250"/>
-            <a:ext cx="1714500" cy="619125"/>
+            <a:off x="13382625" y="4333875"/>
+            <a:ext cx="4524375" cy="1000125"/>
           </a:xfrm>
           <a:prstGeom prst="rect">
             <a:avLst/>
@@ -1221,17 +1221,17 @@
               <a:buNone/>
             </a:pPr>
             <a:r>
-              <a:rPr lang="en-US" sz="1725" dirty="0">
+              <a:rPr lang="en-US" sz="2250" dirty="0">
                 <a:solidFill>
-                  <a:srgbClr val="BED3E4"/>
+                  <a:srgbClr val="283E59"/>
                 </a:solidFill>
                 <a:latin typeface="Inter" pitchFamily="34" charset="0"/>
                 <a:ea typeface="Inter" pitchFamily="34" charset="-122"/>
                 <a:cs typeface="Inter" pitchFamily="34" charset="-120"/>
               </a:rPr>
-              <a:t>Walk. Build strength.</a:t>
-            </a:r>
-            <a:endParaRPr lang="en-US" sz="1725" dirty="0"/>
+              <a:t>A brisk walk after your biggest meal. Strength twice a week.</a:t>
+            </a:r>
+            <a:endParaRPr lang="en-US" sz="2250" dirty="0"/>
           </a:p>
         </p:txBody>
       </p:sp>
@@ -1243,8 +1243,8 @@
         </p:nvSpPr>
         <p:spPr>
           <a:xfrm>
-            <a:off x="12334875" y="8334375"/>
-            <a:ext cx="1714500" cy="571500"/>
+            <a:off x="13335000" y="5334000"/>
+            <a:ext cx="4572000" cy="666750"/>
           </a:xfrm>
           <a:prstGeom prst="rect">
             <a:avLst/>
@@ -1260,17 +1260,17 @@
               <a:buNone/>
             </a:pPr>
             <a:r>
-              <a:rPr lang="en-US" sz="2400" dirty="0">
+              <a:rPr lang="en-US" sz="3675" dirty="0">
                 <a:solidFill>
-                  <a:srgbClr val="F4F1EA"/>
+                  <a:srgbClr val="0A1428"/>
                 </a:solidFill>
                 <a:latin typeface="Playfair Display" pitchFamily="34" charset="0"/>
                 <a:ea typeface="Playfair Display" pitchFamily="34" charset="-122"/>
                 <a:cs typeface="Playfair Display" pitchFamily="34" charset="-120"/>
               </a:rPr>
-              <a:t>Eat better.</a:t>
-            </a:r>
-            <a:endParaRPr lang="en-US" sz="2400" dirty="0"/>
+              <a:t>Watch your sugar.</a:t>
+            </a:r>
+            <a:endParaRPr lang="en-US" sz="3675" dirty="0"/>
           </a:p>
         </p:txBody>
       </p:sp>
@@ -1282,8 +1282,8 @@
         </p:nvSpPr>
         <p:spPr>
           <a:xfrm>
-            <a:off x="12334875" y="8858250"/>
-            <a:ext cx="1714500" cy="619125"/>
+            <a:off x="13382625" y="6000750"/>
+            <a:ext cx="4524375" cy="762000"/>
           </a:xfrm>
           <a:prstGeom prst="rect">
             <a:avLst/>
@@ -1299,17 +1299,17 @@
               <a:buNone/>
             </a:pPr>
             <a:r>
-              <a:rPr lang="en-US" sz="1725" dirty="0">
+              <a:rPr lang="en-US" sz="2250" dirty="0">
                 <a:solidFill>
-                  <a:srgbClr val="BED3E4"/>
+                  <a:srgbClr val="283E59"/>
                 </a:solidFill>
                 <a:latin typeface="Inter" pitchFamily="34" charset="0"/>
                 <a:ea typeface="Inter" pitchFamily="34" charset="-122"/>
                 <a:cs typeface="Inter" pitchFamily="34" charset="-120"/>
               </a:rPr>
-              <a:t>Watch your sugar.</a:t>
-            </a:r>
-            <a:endParaRPr lang="en-US" sz="1725" dirty="0"/>
+              <a:t>Protein and fiber first. Fewer spikes.</a:t>
+            </a:r>
+            <a:endParaRPr lang="en-US" sz="2250" dirty="0"/>
           </a:p>
         </p:txBody>
       </p:sp>
@@ -1321,8 +1321,8 @@
         </p:nvSpPr>
         <p:spPr>
           <a:xfrm>
-            <a:off x="14097000" y="8334375"/>
-            <a:ext cx="1714500" cy="571500"/>
+            <a:off x="13335000" y="6858000"/>
+            <a:ext cx="4572000" cy="666750"/>
           </a:xfrm>
           <a:prstGeom prst="rect">
             <a:avLst/>
@@ -1338,17 +1338,17 @@
               <a:buNone/>
             </a:pPr>
             <a:r>
-              <a:rPr lang="en-US" sz="2400" dirty="0">
+              <a:rPr lang="en-US" sz="3675" dirty="0">
                 <a:solidFill>
-                  <a:srgbClr val="F4F1EA"/>
+                  <a:srgbClr val="0A1428"/>
                 </a:solidFill>
                 <a:latin typeface="Playfair Display" pitchFamily="34" charset="0"/>
                 <a:ea typeface="Playfair Display" pitchFamily="34" charset="-122"/>
                 <a:cs typeface="Playfair Display" pitchFamily="34" charset="-120"/>
               </a:rPr>
-              <a:t>Sleep better.</a:t>
-            </a:r>
-            <a:endParaRPr lang="en-US" sz="2400" dirty="0"/>
+              <a:t>Protect your sleep.</a:t>
+            </a:r>
+            <a:endParaRPr lang="en-US" sz="3675" dirty="0"/>
           </a:p>
         </p:txBody>
       </p:sp>
@@ -1360,8 +1360,8 @@
         </p:nvSpPr>
         <p:spPr>
           <a:xfrm>
-            <a:off x="14097000" y="8858250"/>
-            <a:ext cx="1714500" cy="619125"/>
+            <a:off x="13382625" y="7524750"/>
+            <a:ext cx="4524375" cy="619125"/>
           </a:xfrm>
           <a:prstGeom prst="rect">
             <a:avLst/>
@@ -1377,17 +1377,17 @@
               <a:buNone/>
             </a:pPr>
             <a:r>
-              <a:rPr lang="en-US" sz="1725" dirty="0">
+              <a:rPr lang="en-US" sz="2250" dirty="0">
                 <a:solidFill>
-                  <a:srgbClr val="BED3E4"/>
+                  <a:srgbClr val="283E59"/>
                 </a:solidFill>
                 <a:latin typeface="Inter" pitchFamily="34" charset="0"/>
                 <a:ea typeface="Inter" pitchFamily="34" charset="-122"/>
                 <a:cs typeface="Inter" pitchFamily="34" charset="-120"/>
               </a:rPr>
-              <a:t>Protect your rest.</a:t>
-            </a:r>
-            <a:endParaRPr lang="en-US" sz="1725" dirty="0"/>
+              <a:t>Last meal three hours before bed.</a:t>
+            </a:r>
+            <a:endParaRPr lang="en-US" sz="2250" dirty="0"/>
           </a:p>
         </p:txBody>
       </p:sp>
@@ -1399,8 +1399,8 @@
         </p:nvSpPr>
         <p:spPr>
           <a:xfrm>
-            <a:off x="15906750" y="8334375"/>
-            <a:ext cx="2190750" cy="571500"/>
+            <a:off x="13335000" y="8334375"/>
+            <a:ext cx="4572000" cy="619125"/>
           </a:xfrm>
           <a:prstGeom prst="rect">
             <a:avLst/>
@@ -1416,17 +1416,17 @@
               <a:buNone/>
             </a:pPr>
             <a:r>
-              <a:rPr lang="en-US" sz="2400" i="1" dirty="0">
+              <a:rPr lang="en-US" sz="3525" i="1" dirty="0">
                 <a:solidFill>
-                  <a:srgbClr val="F2D59C"/>
+                  <a:srgbClr val="087F78"/>
                 </a:solidFill>
                 <a:latin typeface="Playfair Display" pitchFamily="34" charset="0"/>
                 <a:ea typeface="Playfair Display" pitchFamily="34" charset="-122"/>
                 <a:cs typeface="Playfair Display" pitchFamily="34" charset="-120"/>
               </a:rPr>
-              <a:t>Your protocol.</a:t>
-            </a:r>
-            <a:endParaRPr lang="en-US" sz="2400" dirty="0"/>
+              <a:t>Your protocol, with us.</a:t>
+            </a:r>
+            <a:endParaRPr lang="en-US" sz="3525" dirty="0"/>
           </a:p>
         </p:txBody>
       </p:sp>
@@ -1438,8 +1438,8 @@
         </p:nvSpPr>
         <p:spPr>
           <a:xfrm>
-            <a:off x="15906750" y="8858250"/>
-            <a:ext cx="2000250" cy="619125"/>
+            <a:off x="13382625" y="9001125"/>
+            <a:ext cx="4524375" cy="1143000"/>
           </a:xfrm>
           <a:prstGeom prst="rect">
             <a:avLst/>
@@ -1455,17 +1455,17 @@
               <a:buNone/>
             </a:pPr>
             <a:r>
-              <a:rPr lang="en-US" sz="1725" dirty="0">
+              <a:rPr lang="en-US" sz="2175" dirty="0">
                 <a:solidFill>
-                  <a:srgbClr val="BED3E4"/>
+                  <a:srgbClr val="283E59"/>
                 </a:solidFill>
                 <a:latin typeface="Inter" pitchFamily="34" charset="0"/>
                 <a:ea typeface="Inter" pitchFamily="34" charset="-122"/>
                 <a:cs typeface="Inter" pitchFamily="34" charset="-120"/>
               </a:rPr>
-              <a:t>The Longevity Blueprint</a:t>
-            </a:r>
-            <a:endParaRPr lang="en-US" sz="1725" dirty="0"/>
+              <a:t>The Longevity Blueprint. Eighteen live weeks, your numbers, a written protocol you keep.</a:t>
+            </a:r>
+            <a:endParaRPr lang="en-US" sz="2175" dirty="0"/>
           </a:p>
         </p:txBody>
       </p:sp>

</xml_diff>